<commit_message>
docs(decks): Say up to 3 instances again in deck and README
Co-Authored-By: Claude Opus 5.5 <noreply@anthropic.com>
</commit_message>
<xml_diff>
--- a/docs/decks/submission_1011.pptx
+++ b/docs/decks/submission_1011.pptx
@@ -23597,7 +23597,7 @@
                 </a:solidFill>
                 <a:latin typeface="Google Sans Flex"/>
               </a:rPr>
-              <a:t>IAP login · one instance · session affinity</a:t>
+              <a:t>IAP login · up to 3 instances · session affinity</a:t>
             </a:r>
           </a:p>
         </p:txBody>
@@ -25198,7 +25198,7 @@
                 </a:solidFill>
                 <a:latin typeface="Google Sans Flex"/>
               </a:rPr>
-              <a:t>us-central1, one instance</a:t>
+              <a:t>us-central1, up to 3 instances</a:t>
             </a:r>
           </a:p>
         </p:txBody>

</xml_diff>